<commit_message>
add code quests for week 2
</commit_message>
<xml_diff>
--- a/material/lectures/week1_opening/framework2.pptx
+++ b/material/lectures/week1_opening/framework2.pptx
@@ -4100,7 +4100,7 @@
         </p:nvSpPr>
         <p:spPr>
           <a:xfrm>
-            <a:off x="713830" y="3429000"/>
+            <a:off x="713830" y="4538891"/>
             <a:ext cx="1620644" cy="680224"/>
           </a:xfrm>
           <a:prstGeom prst="rect">
@@ -4149,7 +4149,7 @@
         </p:nvSpPr>
         <p:spPr>
           <a:xfrm>
-            <a:off x="713830" y="4341540"/>
+            <a:off x="713830" y="5729416"/>
             <a:ext cx="1620644" cy="680224"/>
           </a:xfrm>
           <a:prstGeom prst="rect">
@@ -4601,7 +4601,7 @@
             </a:br>
             <a:r>
               <a:rPr lang="en-NL" sz="1600" dirty="0"/>
-              <a:t>dplyr</a:t>
+              <a:t>dplyr + ITO</a:t>
             </a:r>
           </a:p>
         </p:txBody>
@@ -4620,8 +4620,8 @@
         </p:nvSpPr>
         <p:spPr>
           <a:xfrm>
-            <a:off x="2780626" y="3510543"/>
-            <a:ext cx="1122302" cy="338554"/>
+            <a:off x="2780626" y="4620434"/>
+            <a:ext cx="1122302" cy="1077218"/>
           </a:xfrm>
           <a:prstGeom prst="rect">
             <a:avLst/>
@@ -4640,7 +4640,21 @@
             </a:r>
             <a:r>
               <a:rPr lang="en-NL" sz="1600" dirty="0"/>
-              <a:t>it commit</a:t>
+              <a:t>it status</a:t>
+            </a:r>
+            <a:br>
+              <a:rPr lang="en-NL" sz="1600" dirty="0"/>
+            </a:br>
+            <a:r>
+              <a:rPr lang="en-NL" sz="1600" dirty="0"/>
+              <a:t>git add</a:t>
+            </a:r>
+            <a:br>
+              <a:rPr lang="en-NL" sz="1600" dirty="0"/>
+            </a:br>
+            <a:r>
+              <a:rPr lang="en-NL" sz="1600" dirty="0"/>
+              <a:t>git commit –m</a:t>
             </a:r>
           </a:p>
         </p:txBody>
@@ -4659,7 +4673,7 @@
         </p:nvSpPr>
         <p:spPr>
           <a:xfrm>
-            <a:off x="2780626" y="4311446"/>
+            <a:off x="2780626" y="5699322"/>
             <a:ext cx="1122302" cy="584775"/>
           </a:xfrm>
           <a:prstGeom prst="rect">
@@ -4704,7 +4718,7 @@
         <p:spPr>
           <a:xfrm>
             <a:off x="4045322" y="2546553"/>
-            <a:ext cx="1122302" cy="338554"/>
+            <a:ext cx="1264696" cy="2062103"/>
           </a:xfrm>
           <a:prstGeom prst="rect">
             <a:avLst/>
@@ -4725,6 +4739,66 @@
               <a:rPr lang="nl-NL" sz="1600" dirty="0" err="1"/>
               <a:t>dplyr</a:t>
             </a:r>
+            <a:r>
+              <a:rPr lang="nl-NL" sz="1600" dirty="0"/>
+              <a:t> </a:t>
+            </a:r>
+            <a:r>
+              <a:rPr lang="nl-NL" sz="1600" dirty="0" err="1"/>
+              <a:t>incl.agg</a:t>
+            </a:r>
+            <a:r>
+              <a:rPr lang="nl-NL" sz="1600" dirty="0"/>
+              <a:t>/</a:t>
+            </a:r>
+            <a:r>
+              <a:rPr lang="nl-NL" sz="1600" dirty="0" err="1"/>
+              <a:t>group</a:t>
+            </a:r>
+            <a:r>
+              <a:rPr lang="nl-NL" sz="1600" dirty="0"/>
+              <a:t> </a:t>
+            </a:r>
+            <a:r>
+              <a:rPr lang="nl-NL" sz="1600" dirty="0" err="1"/>
+              <a:t>by</a:t>
+            </a:r>
+            <a:r>
+              <a:rPr lang="nl-NL" sz="1600" dirty="0"/>
+              <a:t> but no </a:t>
+            </a:r>
+            <a:r>
+              <a:rPr lang="nl-NL" sz="1600" dirty="0" err="1"/>
+              <a:t>merge</a:t>
+            </a:r>
+            <a:r>
+              <a:rPr lang="nl-NL" sz="1600" dirty="0"/>
+              <a:t> + summary </a:t>
+            </a:r>
+            <a:r>
+              <a:rPr lang="nl-NL" sz="1600" dirty="0" err="1"/>
+              <a:t>stats</a:t>
+            </a:r>
+            <a:r>
+              <a:rPr lang="nl-NL" sz="1600" dirty="0"/>
+              <a:t>/</a:t>
+            </a:r>
+            <a:r>
+              <a:rPr lang="nl-NL" sz="1600" dirty="0" err="1"/>
+              <a:t>tables</a:t>
+            </a:r>
+            <a:r>
+              <a:rPr lang="nl-NL" sz="1600" dirty="0"/>
+              <a:t> + </a:t>
+            </a:r>
+            <a:r>
+              <a:rPr lang="nl-NL" sz="1600" dirty="0" err="1"/>
+              <a:t>quarto</a:t>
+            </a:r>
+            <a:r>
+              <a:rPr lang="nl-NL" sz="1600" dirty="0"/>
+              <a:t> document</a:t>
+            </a:r>
             <a:endParaRPr lang="en-NL" sz="1600" dirty="0"/>
           </a:p>
         </p:txBody>
@@ -4743,8 +4817,8 @@
         </p:nvSpPr>
         <p:spPr>
           <a:xfrm>
-            <a:off x="4045322" y="3510543"/>
-            <a:ext cx="1122302" cy="584775"/>
+            <a:off x="4045322" y="4620434"/>
+            <a:ext cx="1351868" cy="830997"/>
           </a:xfrm>
           <a:prstGeom prst="rect">
             <a:avLst/>
@@ -4759,8 +4833,21 @@
           <a:p>
             <a:r>
               <a:rPr lang="nl-NL" sz="1600" dirty="0"/>
-              <a:t>git push, </a:t>
-            </a:r>
+              <a:t>git </a:t>
+            </a:r>
+            <a:r>
+              <a:rPr lang="nl-NL" sz="1600" dirty="0" err="1"/>
+              <a:t>clone</a:t>
+            </a:r>
+            <a:endParaRPr lang="nl-NL" sz="1600" dirty="0"/>
+          </a:p>
+          <a:p>
+            <a:r>
+              <a:rPr lang="nl-NL" sz="1600" dirty="0"/>
+              <a:t>git push/pull</a:t>
+            </a:r>
+          </a:p>
+          <a:p>
             <a:r>
               <a:rPr lang="nl-NL" sz="1600" dirty="0" err="1"/>
               <a:t>forking</a:t>
@@ -4783,7 +4870,7 @@
         </p:nvSpPr>
         <p:spPr>
           <a:xfrm>
-            <a:off x="4045322" y="4311446"/>
+            <a:off x="4045322" y="5699322"/>
             <a:ext cx="1122302" cy="338554"/>
           </a:xfrm>
           <a:prstGeom prst="rect">
@@ -4839,7 +4926,7 @@
             </a:r>
             <a:r>
               <a:rPr lang="en-NL" sz="1600" dirty="0"/>
-              <a:t>lotting w/ ggplot2</a:t>
+              <a:t>lotting w/ ggplot2 </a:t>
             </a:r>
           </a:p>
         </p:txBody>
@@ -4858,7 +4945,7 @@
         </p:nvSpPr>
         <p:spPr>
           <a:xfrm>
-            <a:off x="5310018" y="3510543"/>
+            <a:off x="5310018" y="4620434"/>
             <a:ext cx="1122302" cy="338554"/>
           </a:xfrm>
           <a:prstGeom prst="rect">
@@ -4894,7 +4981,7 @@
         </p:nvSpPr>
         <p:spPr>
           <a:xfrm>
-            <a:off x="5310018" y="4311446"/>
+            <a:off x="5310018" y="5699322"/>
             <a:ext cx="1122302" cy="338554"/>
           </a:xfrm>
           <a:prstGeom prst="rect">
@@ -4931,7 +5018,7 @@
         <p:spPr>
           <a:xfrm>
             <a:off x="6574714" y="2546553"/>
-            <a:ext cx="1122302" cy="830997"/>
+            <a:ext cx="1122302" cy="1569660"/>
           </a:xfrm>
           <a:prstGeom prst="rect">
             <a:avLst/>
@@ -4952,6 +5039,26 @@
               <a:rPr lang="nl-NL" sz="1600" dirty="0" err="1"/>
               <a:t>enginee-ring</a:t>
             </a:r>
+            <a:r>
+              <a:rPr lang="nl-NL" sz="1600" dirty="0"/>
+              <a:t>: </a:t>
+            </a:r>
+            <a:r>
+              <a:rPr lang="nl-NL" sz="1600" dirty="0" err="1"/>
+              <a:t>merging</a:t>
+            </a:r>
+            <a:r>
+              <a:rPr lang="nl-NL" sz="1600" dirty="0"/>
+              <a:t>, </a:t>
+            </a:r>
+            <a:r>
+              <a:rPr lang="nl-NL" sz="1600" dirty="0" err="1"/>
+              <a:t>imputation</a:t>
+            </a:r>
+            <a:r>
+              <a:rPr lang="nl-NL" sz="1600" dirty="0"/>
+              <a:t>…</a:t>
+            </a:r>
             <a:endParaRPr lang="en-NL" sz="1600" dirty="0"/>
           </a:p>
         </p:txBody>
@@ -4970,7 +5077,7 @@
         </p:nvSpPr>
         <p:spPr>
           <a:xfrm>
-            <a:off x="6574714" y="3510543"/>
+            <a:off x="6574714" y="4620434"/>
             <a:ext cx="1122302" cy="830997"/>
           </a:xfrm>
           <a:prstGeom prst="rect">
@@ -5012,7 +5119,7 @@
         </p:nvSpPr>
         <p:spPr>
           <a:xfrm>
-            <a:off x="6574714" y="4311446"/>
+            <a:off x="6574714" y="5699322"/>
             <a:ext cx="1122302" cy="830997"/>
           </a:xfrm>
           <a:prstGeom prst="rect">
@@ -5088,7 +5195,7 @@
         </p:nvSpPr>
         <p:spPr>
           <a:xfrm>
-            <a:off x="7839410" y="3510543"/>
+            <a:off x="7839410" y="4620434"/>
             <a:ext cx="1122302" cy="584775"/>
           </a:xfrm>
           <a:prstGeom prst="rect">
@@ -5124,7 +5231,7 @@
         </p:nvSpPr>
         <p:spPr>
           <a:xfrm>
-            <a:off x="7839410" y="4311446"/>
+            <a:off x="7839410" y="5699322"/>
             <a:ext cx="1122302" cy="830997"/>
           </a:xfrm>
           <a:prstGeom prst="rect">

</xml_diff>